<commit_message>
Set deck author and picture descriptions
Author set to tsrnoob66@gmail.com on the cover and in the file
properties; plain Subject and Company fields; short descriptive alt
text on every picture.

Co-Authored-By: Claude Fable 5.1 <noreply@anthropic.com>
Claude-Session: https://claude.ai/code/session_01A3bkjmLHLq973YuWBnz8ka
</commit_message>
<xml_diff>
--- a/Poetry_Anthology.pptx
+++ b/Poetry_Anthology.pptx
@@ -121,13 +121,13 @@
   <p:extLst>
     <p:ext uri="{521415D9-36F7-43E2-AB2F-B90AF26B5E84}">
       <p14:sectionLst xmlns:p14="http://schemas.microsoft.com/office/powerpoint/2010/main">
-        <p14:section name="Front matter" id="{719bd8e7-47af-c9f0-09de-88155765505e}">
+        <p14:section name="Front matter" id="{f9fd45ed-840b-6e78-6ab4-6d257201a971}">
           <p14:sldIdLst>
             <p14:sldId id="256"/>
             <p14:sldId id="257"/>
           </p14:sldIdLst>
         </p14:section>
-        <p14:section name="Seasons" id="{099d9f9b-4f8e-c109-8de1-8747982baafd}">
+        <p14:section name="Seasons" id="{c8f901e2-76d5-ab6b-7399-35f6f20320c6}">
           <p14:sldIdLst>
             <p14:sldId id="258"/>
             <p14:sldId id="259"/>
@@ -139,7 +139,7 @@
             <p14:sldId id="265"/>
           </p14:sldIdLst>
         </p14:section>
-        <p14:section name="Animals" id="{6ef41585-09c2-d8d5-e88f-1da7100e9984}">
+        <p14:section name="Animals" id="{07a21e0b-62ea-c29c-5687-dc97f582fb3a}">
           <p14:sldIdLst>
             <p14:sldId id="266"/>
             <p14:sldId id="267"/>
@@ -147,7 +147,7 @@
             <p14:sldId id="269"/>
           </p14:sldIdLst>
         </p14:section>
-        <p14:section name="Glossary" id="{284df0c2-89fd-02ae-66f7-d4f1318ff96d}">
+        <p14:section name="Glossary" id="{a4245847-7d85-81ff-4592-eed1522cab26}">
           <p14:sldIdLst>
             <p14:sldId id="270"/>
           </p14:sldIdLst>
@@ -2512,7 +2512,7 @@
                 <a:ea typeface="Calibri" pitchFamily="34" charset="-122"/>
                 <a:cs typeface="Calibri" pitchFamily="34" charset="-120"/>
               </a:rPr>
-              <a:t>[Your Name]</a:t>
+              <a:t>tsrnoob66@gmail.com</a:t>
             </a:r>
             <a:endParaRPr lang="en-US" sz="2000" dirty="0"/>
           </a:p>
@@ -2549,7 +2549,7 @@
                 <a:ea typeface="Calibri" pitchFamily="34" charset="-122"/>
                 <a:cs typeface="Calibri" pitchFamily="34" charset="-120"/>
               </a:rPr>
-              <a:t>[Illustrator's Name]</a:t>
+              <a:t>tsrnoob66@gmail.com</a:t>
             </a:r>
             <a:endParaRPr lang="en-US" sz="2000" dirty="0"/>
           </a:p>
@@ -2557,7 +2557,7 @@
       </p:sp>
       <p:pic>
         <p:nvPicPr>
-          <p:cNvPr id="5" name="Four seasons collage" descr="/tmp/claude-0/-home-user-placeholder-/b8f3be13-04b3-5af2-827b-5f3db0b87ecd/scratchpad/build/img/cover.png">    </p:cNvPr>
+          <p:cNvPr id="5" name="Four seasons collage" descr="A tree in spring, summer, autumn and winter">    </p:cNvPr>
           <p:cNvPicPr>
             <a:picLocks noChangeAspect="1"/>
           </p:cNvPicPr>
@@ -3151,7 +3151,7 @@
       </p:sp>
       <p:pic>
         <p:nvPicPr>
-          <p:cNvPr id="5" name="Stopping by Woods on a Snowy Evening picture" descr="/tmp/claude-0/-home-user-placeholder-/b8f3be13-04b3-5af2-827b-5f3db0b87ecd/scratchpad/build/img/woods.png">    </p:cNvPr>
+          <p:cNvPr id="5" name="Stopping by Woods on a Snowy Evening picture" descr="Snowy pine woods at night">    </p:cNvPr>
           <p:cNvPicPr>
             <a:picLocks noChangeAspect="1"/>
           </p:cNvPicPr>
@@ -3839,7 +3839,7 @@
       </p:sp>
       <p:pic>
         <p:nvPicPr>
-          <p:cNvPr id="5" name="The Fox picture" descr="/tmp/claude-0/-home-user-placeholder-/b8f3be13-04b3-5af2-827b-5f3db0b87ecd/scratchpad/build/img/fox.png">    </p:cNvPr>
+          <p:cNvPr id="5" name="The Fox picture" descr="A red fox in a green field">    </p:cNvPr>
           <p:cNvPicPr>
             <a:picLocks noChangeAspect="1"/>
           </p:cNvPicPr>
@@ -4715,7 +4715,7 @@
       </p:sp>
       <p:pic>
         <p:nvPicPr>
-          <p:cNvPr id="6" name="The Tyger picture" descr="/tmp/claude-0/-home-user-placeholder-/b8f3be13-04b3-5af2-827b-5f3db0b87ecd/scratchpad/build/img/tyger.png">    </p:cNvPr>
+          <p:cNvPr id="6" name="The Tyger picture" descr="A tiger face in the jungle">    </p:cNvPr>
           <p:cNvPicPr>
             <a:picLocks noChangeAspect="1"/>
           </p:cNvPicPr>
@@ -5148,7 +5148,7 @@
       </p:sp>
       <p:pic>
         <p:nvPicPr>
-          <p:cNvPr id="5" name="The Eagle picture" descr="/tmp/claude-0/-home-user-placeholder-/b8f3be13-04b3-5af2-827b-5f3db0b87ecd/scratchpad/build/img/eagle.png">    </p:cNvPr>
+          <p:cNvPr id="5" name="The Eagle picture" descr="An eagle on a cliff above the sea">    </p:cNvPr>
           <p:cNvPicPr>
             <a:picLocks noChangeAspect="1"/>
           </p:cNvPicPr>
@@ -5857,7 +5857,7 @@
       </p:sp>
       <p:pic>
         <p:nvPicPr>
-          <p:cNvPr id="5" name="Book picture" descr="/tmp/claude-0/-home-user-placeholder-/b8f3be13-04b3-5af2-827b-5f3db0b87ecd/scratchpad/build/img/glossary.png">    </p:cNvPr>
+          <p:cNvPr id="5" name="Book picture" descr="An open book">    </p:cNvPr>
           <p:cNvPicPr>
             <a:picLocks noChangeAspect="1"/>
           </p:cNvPicPr>
@@ -7115,7 +7115,7 @@
       </p:graphicFrame>
       <p:pic>
         <p:nvPicPr>
-          <p:cNvPr id="4" name="Leaf branch picture" descr="/tmp/claude-0/-home-user-placeholder-/b8f3be13-04b3-5af2-827b-5f3db0b87ecd/scratchpad/build/img/toc.png">    </p:cNvPr>
+          <p:cNvPr id="4" name="Leaf branch picture" descr="A branch with green leaves">    </p:cNvPr>
           <p:cNvPicPr>
             <a:picLocks noChangeAspect="1"/>
           </p:cNvPicPr>
@@ -7683,7 +7683,7 @@
       </p:sp>
       <p:pic>
         <p:nvPicPr>
-          <p:cNvPr id="5" name="Spring Wakes Up picture" descr="/tmp/claude-0/-home-user-placeholder-/b8f3be13-04b3-5af2-827b-5f3db0b87ecd/scratchpad/build/img/spring.png">    </p:cNvPr>
+          <p:cNvPr id="5" name="Spring Wakes Up picture" descr="Cherry blossom tree in spring">    </p:cNvPr>
           <p:cNvPicPr>
             <a:picLocks noChangeAspect="1"/>
           </p:cNvPicPr>
@@ -8137,7 +8137,7 @@
       </p:sp>
       <p:pic>
         <p:nvPicPr>
-          <p:cNvPr id="5" name="Nothing Gold Can Stay picture" descr="/tmp/claude-0/-home-user-placeholder-/b8f3be13-04b3-5af2-827b-5f3db0b87ecd/scratchpad/build/img/gold.png">    </p:cNvPr>
+          <p:cNvPr id="5" name="Nothing Gold Can Stay picture" descr="Branch with golden leaves in the sun">    </p:cNvPr>
           <p:cNvPicPr>
             <a:picLocks noChangeAspect="1"/>
           </p:cNvPicPr>
@@ -8631,7 +8631,7 @@
       </p:sp>
       <p:pic>
         <p:nvPicPr>
-          <p:cNvPr id="5" name="Summer Afternoon picture" descr="/tmp/claude-0/-home-user-placeholder-/b8f3be13-04b3-5af2-827b-5f3db0b87ecd/scratchpad/build/img/summer.png">    </p:cNvPr>
+          <p:cNvPr id="5" name="Summer Afternoon picture" descr="Sunny beach with a parasol">    </p:cNvPr>
           <p:cNvPicPr>
             <a:picLocks noChangeAspect="1"/>
           </p:cNvPicPr>
@@ -10117,7 +10117,7 @@
       </p:sp>
       <p:pic>
         <p:nvPicPr>
-          <p:cNvPr id="5" name="Letting Go picture" descr="/tmp/claude-0/-home-user-placeholder-/b8f3be13-04b3-5af2-827b-5f3db0b87ecd/scratchpad/build/img/autumnMine.png">    </p:cNvPr>
+          <p:cNvPr id="5" name="Letting Go picture" descr="Red maple tree dropping its leaves">    </p:cNvPr>
           <p:cNvPicPr>
             <a:picLocks noChangeAspect="1"/>
           </p:cNvPicPr>
@@ -10631,7 +10631,7 @@
       </p:sp>
       <p:pic>
         <p:nvPicPr>
-          <p:cNvPr id="5" name="Winter Haiku picture" descr="/tmp/claude-0/-home-user-placeholder-/b8f3be13-04b3-5af2-827b-5f3db0b87ecd/scratchpad/build/img/winter.png">    </p:cNvPr>
+          <p:cNvPr id="5" name="Winter Haiku picture" descr="Snow falling on a small house and a bare tree">    </p:cNvPr>
           <p:cNvPicPr>
             <a:picLocks noChangeAspect="1"/>
           </p:cNvPicPr>

</xml_diff>

<commit_message>
Set author to Lanzi Wang and keep cover and dedication edits
Co-Authored-By: Claude Fable 5.1 <noreply@anthropic.com>
Claude-Session: https://claude.ai/code/session_01A3bkjmLHLq973YuWBnz8ka
</commit_message>
<xml_diff>
--- a/Poetry_Anthology.pptx
+++ b/Poetry_Anthology.pptx
@@ -121,13 +121,13 @@
   <p:extLst>
     <p:ext uri="{521415D9-36F7-43E2-AB2F-B90AF26B5E84}">
       <p14:sectionLst xmlns:p14="http://schemas.microsoft.com/office/powerpoint/2010/main">
-        <p14:section name="Front matter" id="{f9fd45ed-840b-6e78-6ab4-6d257201a971}">
+        <p14:section name="Front matter" id="{dff38890-b9a4-5c4b-cb0b-45f9d18ecfe8}">
           <p14:sldIdLst>
             <p14:sldId id="256"/>
             <p14:sldId id="257"/>
           </p14:sldIdLst>
         </p14:section>
-        <p14:section name="Seasons" id="{c8f901e2-76d5-ab6b-7399-35f6f20320c6}">
+        <p14:section name="Seasons" id="{df46bb05-5148-8bf8-2b6f-8715233c72dc}">
           <p14:sldIdLst>
             <p14:sldId id="258"/>
             <p14:sldId id="259"/>
@@ -139,7 +139,7 @@
             <p14:sldId id="265"/>
           </p14:sldIdLst>
         </p14:section>
-        <p14:section name="Animals" id="{07a21e0b-62ea-c29c-5687-dc97f582fb3a}">
+        <p14:section name="Animals" id="{f2a297fa-463e-1f80-da13-b79cff9805c8}">
           <p14:sldIdLst>
             <p14:sldId id="266"/>
             <p14:sldId id="267"/>
@@ -147,7 +147,7 @@
             <p14:sldId id="269"/>
           </p14:sldIdLst>
         </p14:section>
-        <p14:section name="Glossary" id="{a4245847-7d85-81ff-4592-eed1522cab26}">
+        <p14:section name="Glossary" id="{329a514e-538b-ea37-1355-5ac27e4ec4a6}">
           <p14:sldIdLst>
             <p14:sldId id="270"/>
           </p14:sldIdLst>
@@ -2495,7 +2495,7 @@
                 <a:ea typeface="Calibri" pitchFamily="34" charset="-122"/>
                 <a:cs typeface="Calibri" pitchFamily="34" charset="-120"/>
               </a:rPr>
-              <a:t>Written by </a:t>
+              <a:t>Made by </a:t>
             </a:r>
             <a:pPr indent="0" marL="0">
               <a:lnSpc>
@@ -2512,44 +2512,7 @@
                 <a:ea typeface="Calibri" pitchFamily="34" charset="-122"/>
                 <a:cs typeface="Calibri" pitchFamily="34" charset="-120"/>
               </a:rPr>
-              <a:t>tsrnoob66@gmail.com</a:t>
-            </a:r>
-            <a:endParaRPr lang="en-US" sz="2000" dirty="0"/>
-          </a:p>
-          <a:p>
-            <a:pPr indent="0" marL="0">
-              <a:lnSpc>
-                <a:spcPct val="120000"/>
-              </a:lnSpc>
-              <a:buNone/>
-            </a:pPr>
-            <a:r>
-              <a:rPr lang="en-US" sz="2000" dirty="0">
-                <a:solidFill>
-                  <a:schemeClr val="accent5"/>
-                </a:solidFill>
-                <a:latin typeface="Calibri" pitchFamily="34" charset="0"/>
-                <a:ea typeface="Calibri" pitchFamily="34" charset="-122"/>
-                <a:cs typeface="Calibri" pitchFamily="34" charset="-120"/>
-              </a:rPr>
-              <a:t>Illustrated by </a:t>
-            </a:r>
-            <a:pPr indent="0" marL="0">
-              <a:lnSpc>
-                <a:spcPct val="120000"/>
-              </a:lnSpc>
-              <a:buNone/>
-            </a:pPr>
-            <a:r>
-              <a:rPr lang="en-US" sz="2000" b="1" dirty="0">
-                <a:solidFill>
-                  <a:schemeClr val="tx1"/>
-                </a:solidFill>
-                <a:latin typeface="Calibri" pitchFamily="34" charset="0"/>
-                <a:ea typeface="Calibri" pitchFamily="34" charset="-122"/>
-                <a:cs typeface="Calibri" pitchFamily="34" charset="-120"/>
-              </a:rPr>
-              <a:t>tsrnoob66@gmail.com</a:t>
+              <a:t>Lanzi Wang</a:t>
             </a:r>
             <a:endParaRPr lang="en-US" sz="2000" dirty="0"/>
           </a:p>
@@ -8727,7 +8690,7 @@
                 <a:ea typeface="Calibri" pitchFamily="34" charset="-122"/>
                 <a:cs typeface="Calibri" pitchFamily="34" charset="-120"/>
               </a:rPr>
-              <a:t>I dedicate this poem to my dog, Max, because he taught me how to do nothing on a hot day.</a:t>
+              <a:t>I dedicate this poem to a cute dog I met because he taught me how to do nothing on a hot day.</a:t>
             </a:r>
             <a:endParaRPr lang="en-US" sz="1800" dirty="0"/>
           </a:p>

</xml_diff>

<commit_message>
Replace drawn illustrations with photos
Co-Authored-By: Claude Fable 5.1 <noreply@anthropic.com>
Claude-Session: https://claude.ai/code/session_01A3bkjmLHLq973YuWBnz8ka
</commit_message>
<xml_diff>
--- a/Poetry_Anthology.pptx
+++ b/Poetry_Anthology.pptx
@@ -121,13 +121,13 @@
   <p:extLst>
     <p:ext uri="{521415D9-36F7-43E2-AB2F-B90AF26B5E84}">
       <p14:sectionLst xmlns:p14="http://schemas.microsoft.com/office/powerpoint/2010/main">
-        <p14:section name="Front matter" id="{dff38890-b9a4-5c4b-cb0b-45f9d18ecfe8}">
+        <p14:section name="Front matter" id="{ca1e0a21-0391-cd94-ce58-72f131f75c81}">
           <p14:sldIdLst>
             <p14:sldId id="256"/>
             <p14:sldId id="257"/>
           </p14:sldIdLst>
         </p14:section>
-        <p14:section name="Seasons" id="{df46bb05-5148-8bf8-2b6f-8715233c72dc}">
+        <p14:section name="Seasons" id="{8a3fa09c-8c4c-a6f0-8bbe-73cf3c9ebfb0}">
           <p14:sldIdLst>
             <p14:sldId id="258"/>
             <p14:sldId id="259"/>
@@ -139,7 +139,7 @@
             <p14:sldId id="265"/>
           </p14:sldIdLst>
         </p14:section>
-        <p14:section name="Animals" id="{f2a297fa-463e-1f80-da13-b79cff9805c8}">
+        <p14:section name="Animals" id="{5de762fc-6c5d-7b42-d1f6-17f1cd9825e5}">
           <p14:sldIdLst>
             <p14:sldId id="266"/>
             <p14:sldId id="267"/>
@@ -147,7 +147,7 @@
             <p14:sldId id="269"/>
           </p14:sldIdLst>
         </p14:section>
-        <p14:section name="Glossary" id="{329a514e-538b-ea37-1355-5ac27e4ec4a6}">
+        <p14:section name="Glossary" id="{50eb5fef-a45c-1d80-1116-0b1704b419bc}">
           <p14:sldIdLst>
             <p14:sldId id="270"/>
           </p14:sldIdLst>
@@ -556,7 +556,7 @@
           <a:p>
             <a:r>
               <a:rPr lang="en-US" dirty="0"/>
-              <a:t>Photo idea: a tree in all four seasons, or a four-season collage. Unsplash search: 'four seasons tree'.</a:t>
+              <a:t/>
             </a:r>
             <a:endParaRPr lang="en-US" dirty="0"/>
           </a:p>
@@ -644,7 +644,7 @@
           <a:p>
             <a:r>
               <a:rPr lang="en-US" dirty="0"/>
-              <a:t>Photo idea: snowy woods in the evening. Unsplash search: 'snowy forest evening'.</a:t>
+              <a:t/>
             </a:r>
             <a:endParaRPr lang="en-US" dirty="0"/>
           </a:p>
@@ -732,7 +732,7 @@
           <a:p>
             <a:r>
               <a:rPr lang="en-US" dirty="0"/>
-              <a:t>Photo idea: animal tracks in snow or a dark forest. Unsplash search: 'animal tracks snow'.</a:t>
+              <a:t/>
             </a:r>
             <a:endParaRPr lang="en-US" dirty="0"/>
           </a:p>
@@ -820,7 +820,7 @@
           <a:p>
             <a:r>
               <a:rPr lang="en-US" dirty="0"/>
-              <a:t>Photo idea: a red fox in a field. Unsplash search: 'red fox field'.</a:t>
+              <a:t/>
             </a:r>
             <a:endParaRPr lang="en-US" dirty="0"/>
           </a:p>
@@ -908,7 +908,7 @@
           <a:p>
             <a:r>
               <a:rPr lang="en-US" dirty="0"/>
-              <a:t>Photo idea: tiger close-up. Unsplash search: 'tiger face close up'.</a:t>
+              <a:t/>
             </a:r>
             <a:endParaRPr lang="en-US" dirty="0"/>
           </a:p>
@@ -996,7 +996,7 @@
           <a:p>
             <a:r>
               <a:rPr lang="en-US" dirty="0"/>
-              <a:t>Photo idea: an eagle on a cliff above the sea. Unsplash search: 'eagle cliff sea'.</a:t>
+              <a:t/>
             </a:r>
             <a:endParaRPr lang="en-US" dirty="0"/>
           </a:p>
@@ -1084,7 +1084,7 @@
           <a:p>
             <a:r>
               <a:rPr lang="en-US" dirty="0"/>
-              <a:t>Plain background with a simple picture. Unsplash search: 'open book plain background'.</a:t>
+              <a:t/>
             </a:r>
             <a:endParaRPr lang="en-US" dirty="0"/>
           </a:p>
@@ -1172,7 +1172,7 @@
           <a:p>
             <a:r>
               <a:rPr lang="en-US" dirty="0"/>
-              <a:t>Photo idea: a small leaf or branch border. Unsplash search: 'green branch white background'.</a:t>
+              <a:t/>
             </a:r>
             <a:endParaRPr lang="en-US" dirty="0"/>
           </a:p>
@@ -1260,7 +1260,7 @@
           <a:p>
             <a:r>
               <a:rPr lang="en-US" dirty="0"/>
-              <a:t>Photo idea: a wide landscape photo. Unsplash search: 'rolling hills landscape'.</a:t>
+              <a:t/>
             </a:r>
             <a:endParaRPr lang="en-US" dirty="0"/>
           </a:p>
@@ -1348,7 +1348,7 @@
           <a:p>
             <a:r>
               <a:rPr lang="en-US" dirty="0"/>
-              <a:t>Photo idea: cherry blossoms. Unsplash search: 'cherry blossom tree'.</a:t>
+              <a:t/>
             </a:r>
             <a:endParaRPr lang="en-US" dirty="0"/>
           </a:p>
@@ -1436,7 +1436,7 @@
           <a:p>
             <a:r>
               <a:rPr lang="en-US" dirty="0"/>
-              <a:t>Photo idea: new golden-green leaves in the sun. Unsplash search: 'new leaves spring sunlight'.</a:t>
+              <a:t/>
             </a:r>
             <a:endParaRPr lang="en-US" dirty="0"/>
           </a:p>
@@ -1524,7 +1524,7 @@
           <a:p>
             <a:r>
               <a:rPr lang="en-US" dirty="0"/>
-              <a:t>Photo idea: a sunny beach. Unsplash search: 'sunny beach'.</a:t>
+              <a:t/>
             </a:r>
             <a:endParaRPr lang="en-US" dirty="0"/>
           </a:p>
@@ -1612,7 +1612,7 @@
           <a:p>
             <a:r>
               <a:rPr lang="en-US" dirty="0"/>
-              <a:t>Photo idea: autumn leaves or an orchard, placed behind the text and darkened so the poem stays readable. Unsplash search: 'autumn orchard'.</a:t>
+              <a:t/>
             </a:r>
             <a:endParaRPr lang="en-US" dirty="0"/>
           </a:p>
@@ -1700,7 +1700,7 @@
           <a:p>
             <a:r>
               <a:rPr lang="en-US" dirty="0"/>
-              <a:t>Photo idea: a red maple dropping its leaves. Unsplash search: 'red maple autumn leaves'.</a:t>
+              <a:t/>
             </a:r>
             <a:endParaRPr lang="en-US" dirty="0"/>
           </a:p>
@@ -1788,7 +1788,7 @@
           <a:p>
             <a:r>
               <a:rPr lang="en-US" dirty="0"/>
-              <a:t>Photo idea: first snow on rooftops. Unsplash search: 'snow on roof village'.</a:t>
+              <a:t/>
             </a:r>
             <a:endParaRPr lang="en-US" dirty="0"/>
           </a:p>
@@ -2534,8 +2534,8 @@
         </p:blipFill>
         <p:spPr>
           <a:xfrm>
-            <a:off x="6583680" y="502920"/>
-            <a:ext cx="5394960" cy="5852160"/>
+            <a:off x="6583680" y="1543383"/>
+            <a:ext cx="5394960" cy="3771234"/>
           </a:xfrm>
           <a:prstGeom prst="rect">
             <a:avLst/>

</xml_diff>